<commit_message>
Wire TRIAD MailerLite capture: live group, LinkedIn field, hosted form; real QR in both decks
Group, custom field, and embedded form created in the TRIAD account (2493801);
form share URL embedded as QR in slide 9 of pptx and HTML decks. Runbook updated
with live asset IDs and a DMARC/sender warning for the kit email.

Co-Authored-By: Claude Fable 5 <noreply@anthropic.com>
Claude-Session: https://claude.ai/code/session_01WN7CJrbeGGL85GrNVdD1gE
</commit_message>
<xml_diff>
--- a/proof-to-pipeline/deck/EAIO_TriadSynergy_Deck_V1.pptx
+++ b/proof-to-pipeline/deck/EAIO_TriadSynergy_Deck_V1.pptx
@@ -8139,82 +8139,33 @@
           <a:ln/>
         </p:spPr>
       </p:sp>
-      <p:sp>
-        <p:nvSpPr>
-          <p:cNvPr id="8" name="Text 6"/>
-          <p:cNvSpPr/>
-          <p:nvPr/>
-        </p:nvSpPr>
-        <p:spPr>
-          <a:xfrm>
-            <a:off x="6400800" y="1325880"/>
-            <a:ext cx="2103120" cy="1737360"/>
-          </a:xfrm>
-          <a:prstGeom prst="rect">
-            <a:avLst/>
-          </a:prstGeom>
-          <a:noFill/>
-          <a:ln/>
-        </p:spPr>
-        <p:txBody>
-          <a:bodyPr wrap="square" rtlCol="0" anchor="ctr"/>
-          <a:lstStyle/>
-          <a:p>
-            <a:pPr algn="ctr" indent="0" marL="0">
-              <a:buNone/>
-            </a:pPr>
-            <a:r>
-              <a:rPr lang="en-US" sz="1200" b="1" dirty="0">
-                <a:solidFill>
-                  <a:srgbClr val="1F3A4D"/>
-                </a:solidFill>
-                <a:latin typeface="Calibri" pitchFamily="34" charset="0"/>
-                <a:ea typeface="Calibri" pitchFamily="34" charset="-122"/>
-                <a:cs typeface="Calibri" pitchFamily="34" charset="-120"/>
-              </a:rPr>
-              <a:t>QR</a:t>
-            </a:r>
-            <a:endParaRPr lang="en-US" sz="1200" dirty="0"/>
-          </a:p>
-          <a:p>
-            <a:pPr algn="ctr" indent="0" marL="0">
-              <a:buNone/>
-            </a:pPr>
-            <a:r>
-              <a:rPr lang="en-US" sz="1200" b="1" dirty="0">
-                <a:solidFill>
-                  <a:srgbClr val="1F3A4D"/>
-                </a:solidFill>
-                <a:latin typeface="Calibri" pitchFamily="34" charset="0"/>
-                <a:ea typeface="Calibri" pitchFamily="34" charset="-122"/>
-                <a:cs typeface="Calibri" pitchFamily="34" charset="-120"/>
-              </a:rPr>
-              <a:t>(form link —</a:t>
-            </a:r>
-            <a:endParaRPr lang="en-US" sz="1200" dirty="0"/>
-          </a:p>
-          <a:p>
-            <a:pPr algn="ctr" indent="0" marL="0">
-              <a:buNone/>
-            </a:pPr>
-            <a:r>
-              <a:rPr lang="en-US" sz="1200" b="1" dirty="0">
-                <a:solidFill>
-                  <a:srgbClr val="1F3A4D"/>
-                </a:solidFill>
-                <a:latin typeface="Calibri" pitchFamily="34" charset="0"/>
-                <a:ea typeface="Calibri" pitchFamily="34" charset="-122"/>
-                <a:cs typeface="Calibri" pitchFamily="34" charset="-120"/>
-              </a:rPr>
-              <a:t>also in chat)</a:t>
-            </a:r>
-            <a:endParaRPr lang="en-US" sz="1200" dirty="0"/>
-          </a:p>
-        </p:txBody>
-      </p:sp>
-      <p:sp>
-        <p:nvSpPr>
-          <p:cNvPr id="9" name="Text 7"/>
+      <p:pic>
+        <p:nvPicPr>
+          <p:cNvPr id="8" name="Image 0" descr="/home/user/agnt-neo/proof-to-pipeline/deck/form_qr.png">    </p:cNvPr>
+          <p:cNvPicPr>
+            <a:picLocks noChangeAspect="1"/>
+          </p:cNvPicPr>
+          <p:nvPr/>
+        </p:nvPicPr>
+        <p:blipFill>
+          <a:blip r:embed="rId1"/>
+          <a:stretch>
+            <a:fillRect/>
+          </a:stretch>
+        </p:blipFill>
+        <p:spPr>
+          <a:xfrm>
+            <a:off x="6556248" y="1371600"/>
+            <a:ext cx="1645920" cy="1645920"/>
+          </a:xfrm>
+          <a:prstGeom prst="rect">
+            <a:avLst/>
+          </a:prstGeom>
+        </p:spPr>
+      </p:pic>
+      <p:sp>
+        <p:nvSpPr>
+          <p:cNvPr id="9" name="Text 6"/>
           <p:cNvSpPr/>
           <p:nvPr/>
         </p:nvSpPr>
@@ -8267,7 +8218,7 @@
       </p:sp>
       <p:sp>
         <p:nvSpPr>
-          <p:cNvPr id="10" name="Text 8"/>
+          <p:cNvPr id="10" name="Text 7"/>
           <p:cNvSpPr/>
           <p:nvPr/>
         </p:nvSpPr>
@@ -8306,7 +8257,7 @@
       </p:sp>
       <p:sp>
         <p:nvSpPr>
-          <p:cNvPr id="11" name="Text 9"/>
+          <p:cNvPr id="11" name="Text 8"/>
           <p:cNvSpPr/>
           <p:nvPr/>
         </p:nvSpPr>
@@ -8345,7 +8296,7 @@
       </p:sp>
       <p:sp>
         <p:nvSpPr>
-          <p:cNvPr id="12" name="Text 10"/>
+          <p:cNvPr id="12" name="Text 9"/>
           <p:cNvSpPr/>
           <p:nvPr/>
         </p:nvSpPr>

</xml_diff>

<commit_message>
Replace I·We·It framing with three-questions framing
Method slide becomes 'Three questions every ending must answer'
(Q1 What do we actually have? / Q2 Who deserves a goodbye? /
Q3 What lives on?). Section slides retitled with Q1/Q2/Q3 corner
keys; TRIAD colors retained. Decision register amended (A1).

Co-Authored-By: Claude Fable 5 <noreply@anthropic.com>
Claude-Session: https://claude.ai/code/session_018x8uMgQwwUF8tnVHZESapZ
</commit_message>
<xml_diff>
--- a/proof-to-pipeline/deck/EAIO_TriadSynergy_Deck_V1.pptx
+++ b/proof-to-pipeline/deck/EAIO_TriadSynergy_Deck_V1.pptx
@@ -863,7 +863,7 @@
           <a:p>
             <a:r>
               <a:rPr lang="en-US" dirty="0"/>
-              <a:t>2:00–3:00. This is the map for the next three slides — watch the key in the corner. The framework is the brand and the brand is the framework.</a:t>
+              <a:t>2:00–3:00. This is the map for the next three slides — watch the Q1/Q2/Q3 key in the corner. Each question gets answered with real artifacts from the ARC engagement.</a:t>
             </a:r>
             <a:endParaRPr lang="en-US" dirty="0"/>
           </a:p>
@@ -1215,7 +1215,7 @@
           <a:p>
             <a:r>
               <a:rPr lang="en-US" dirty="0"/>
-              <a:t>7:30–8:30. The I of the triad: leadership through an ending. The fund amount now appears on the mandate slide — remove it there if Mike's written consent (due Tue Aug 18) doesn't cover it; this slide stays general. Land the positioning line.</a:t>
+              <a:t>7:30–8:30. Q3 — leadership through an ending. The fund amount now appears on the mandate slide — remove it there if Mike's written consent (due Tue Aug 18) doesn't cover it; this slide stays general. Land the positioning line.</a:t>
             </a:r>
             <a:endParaRPr lang="en-US" dirty="0"/>
           </a:p>
@@ -4033,7 +4033,7 @@
                 <a:ea typeface="Cambria" pitchFamily="34" charset="-122"/>
                 <a:cs typeface="Cambria" pitchFamily="34" charset="-120"/>
               </a:rPr>
-              <a:t>The method: I · We · It</a:t>
+              <a:t>Three questions every ending must answer</a:t>
             </a:r>
             <a:endParaRPr lang="en-US" sz="3000" dirty="0"/>
           </a:p>
@@ -4047,92 +4047,66 @@
         </p:nvSpPr>
         <p:spPr>
           <a:xfrm>
-            <a:off x="1490472" y="1417320"/>
-            <a:ext cx="768096" cy="768096"/>
-          </a:xfrm>
-          <a:prstGeom prst="ellipse">
-            <a:avLst/>
+            <a:off x="502920" y="1143000"/>
+            <a:ext cx="8138160" cy="914400"/>
+          </a:xfrm>
+          <a:prstGeom prst="roundRect">
+            <a:avLst>
+              <a:gd name="adj" fmla="val 9000"/>
+            </a:avLst>
           </a:prstGeom>
           <a:solidFill>
-            <a:srgbClr val="1F3A4D"/>
+            <a:srgbClr val="FFFFFF"/>
           </a:solidFill>
-          <a:ln/>
-        </p:spPr>
-      </p:sp>
-      <p:sp>
-        <p:nvSpPr>
-          <p:cNvPr id="4" name="Shape 2"/>
-          <p:cNvSpPr/>
-          <p:nvPr/>
-        </p:nvSpPr>
-        <p:spPr>
-          <a:xfrm>
-            <a:off x="576072" y="3017520"/>
-            <a:ext cx="768096" cy="768096"/>
-          </a:xfrm>
-          <a:prstGeom prst="ellipse">
-            <a:avLst/>
-          </a:prstGeom>
-          <a:solidFill>
-            <a:srgbClr val="2E6E6E"/>
-          </a:solidFill>
-          <a:ln/>
-        </p:spPr>
-      </p:sp>
-      <p:sp>
-        <p:nvSpPr>
-          <p:cNvPr id="5" name="Shape 3"/>
-          <p:cNvSpPr/>
-          <p:nvPr/>
-        </p:nvSpPr>
-        <p:spPr>
-          <a:xfrm>
-            <a:off x="2404872" y="3017520"/>
-            <a:ext cx="768096" cy="768096"/>
-          </a:xfrm>
-          <a:prstGeom prst="ellipse">
-            <a:avLst/>
-          </a:prstGeom>
-          <a:solidFill>
-            <a:srgbClr val="C08A2E"/>
-          </a:solidFill>
-          <a:ln/>
-        </p:spPr>
-      </p:sp>
-      <p:sp>
-        <p:nvSpPr>
-          <p:cNvPr id="6" name="Text 4"/>
-          <p:cNvSpPr/>
-          <p:nvPr/>
-        </p:nvSpPr>
-        <p:spPr>
-          <a:xfrm>
-            <a:off x="1490472" y="1417320"/>
-            <a:ext cx="768096" cy="768096"/>
-          </a:xfrm>
-          <a:prstGeom prst="rect">
-            <a:avLst/>
-          </a:prstGeom>
-          <a:noFill/>
-          <a:ln/>
-        </p:spPr>
-        <p:txBody>
-          <a:bodyPr wrap="square" lIns="0" tIns="0" rIns="0" bIns="0" rtlCol="0" anchor="ctr"/>
-          <a:lstStyle/>
-          <a:p>
-            <a:pPr algn="ctr" indent="0" marL="0">
+          <a:ln w="12700">
+            <a:solidFill>
+              <a:srgbClr val="D5DFE1"/>
+            </a:solidFill>
+            <a:prstDash val="solid"/>
+          </a:ln>
+          <a:effectLst>
+            <a:outerShdw sx="100000" sy="100000" kx="0" ky="0" algn="bl" rotWithShape="0" blurRad="76200" dist="25400" dir="5400000">
+              <a:srgbClr val="AEB9BD">
+                <a:alpha val="25000"/>
+              </a:srgbClr>
+            </a:outerShdw>
+          </a:effectLst>
+        </p:spPr>
+      </p:sp>
+      <p:sp>
+        <p:nvSpPr>
+          <p:cNvPr id="4" name="Text 2"/>
+          <p:cNvSpPr/>
+          <p:nvPr/>
+        </p:nvSpPr>
+        <p:spPr>
+          <a:xfrm>
+            <a:off x="777240" y="1143000"/>
+            <a:ext cx="777240" cy="914400"/>
+          </a:xfrm>
+          <a:prstGeom prst="rect">
+            <a:avLst/>
+          </a:prstGeom>
+          <a:noFill/>
+          <a:ln/>
+        </p:spPr>
+        <p:txBody>
+          <a:bodyPr wrap="square" lIns="0" tIns="0" rIns="0" bIns="0" rtlCol="0" anchor="ctr"/>
+          <a:lstStyle/>
+          <a:p>
+            <a:pPr indent="0" marL="0">
               <a:buNone/>
             </a:pPr>
             <a:r>
               <a:rPr lang="en-US" sz="2600" b="1" dirty="0">
                 <a:solidFill>
-                  <a:srgbClr val="FFFFFF"/>
+                  <a:srgbClr val="C08A2E"/>
                 </a:solidFill>
                 <a:latin typeface="Cambria" pitchFamily="34" charset="0"/>
                 <a:ea typeface="Cambria" pitchFamily="34" charset="-122"/>
                 <a:cs typeface="Cambria" pitchFamily="34" charset="-120"/>
               </a:rPr>
-              <a:t>I</a:t>
+              <a:t>Q1</a:t>
             </a:r>
             <a:endParaRPr lang="en-US" sz="2600" dirty="0"/>
           </a:p>
@@ -4140,40 +4114,136 @@
       </p:sp>
       <p:sp>
         <p:nvSpPr>
+          <p:cNvPr id="5" name="Text 3"/>
+          <p:cNvSpPr/>
+          <p:nvPr/>
+        </p:nvSpPr>
+        <p:spPr>
+          <a:xfrm>
+            <a:off x="1691640" y="1271016"/>
+            <a:ext cx="6766560" cy="685800"/>
+          </a:xfrm>
+          <a:prstGeom prst="rect">
+            <a:avLst/>
+          </a:prstGeom>
+          <a:noFill/>
+          <a:ln/>
+        </p:spPr>
+        <p:txBody>
+          <a:bodyPr wrap="square" lIns="0" tIns="0" rIns="0" bIns="0" rtlCol="0" anchor="ctr"/>
+          <a:lstStyle/>
+          <a:p>
+            <a:pPr indent="0" marL="0">
+              <a:lnSpc>
+                <a:spcPct val="112000"/>
+              </a:lnSpc>
+              <a:buNone/>
+            </a:pPr>
+            <a:r>
+              <a:rPr lang="en-US" sz="1700" b="1" dirty="0">
+                <a:solidFill>
+                  <a:srgbClr val="22313D"/>
+                </a:solidFill>
+                <a:latin typeface="Calibri" pitchFamily="34" charset="0"/>
+                <a:ea typeface="Calibri" pitchFamily="34" charset="-122"/>
+                <a:cs typeface="Calibri" pitchFamily="34" charset="-120"/>
+              </a:rPr>
+              <a:t>What do we actually have?</a:t>
+            </a:r>
+            <a:endParaRPr lang="en-US" sz="1700" dirty="0"/>
+          </a:p>
+          <a:p>
+            <a:pPr indent="0" marL="0">
+              <a:lnSpc>
+                <a:spcPct val="112000"/>
+              </a:lnSpc>
+              <a:buNone/>
+            </a:pPr>
+            <a:r>
+              <a:rPr lang="en-US" sz="1150" dirty="0">
+                <a:solidFill>
+                  <a:srgbClr val="888888"/>
+                </a:solidFill>
+                <a:latin typeface="Calibri" pitchFamily="34" charset="0"/>
+                <a:ea typeface="Calibri" pitchFamily="34" charset="-122"/>
+                <a:cs typeface="Calibri" pitchFamily="34" charset="-120"/>
+              </a:rPr>
+              <a:t>Records, money, tech, data — the institutional memory. Answered by forensic reconstruction.</a:t>
+            </a:r>
+            <a:endParaRPr lang="en-US" sz="1700" dirty="0"/>
+          </a:p>
+        </p:txBody>
+      </p:sp>
+      <p:sp>
+        <p:nvSpPr>
+          <p:cNvPr id="6" name="Shape 4"/>
+          <p:cNvSpPr/>
+          <p:nvPr/>
+        </p:nvSpPr>
+        <p:spPr>
+          <a:xfrm>
+            <a:off x="502920" y="2221992"/>
+            <a:ext cx="8138160" cy="914400"/>
+          </a:xfrm>
+          <a:prstGeom prst="roundRect">
+            <a:avLst>
+              <a:gd name="adj" fmla="val 9000"/>
+            </a:avLst>
+          </a:prstGeom>
+          <a:solidFill>
+            <a:srgbClr val="FFFFFF"/>
+          </a:solidFill>
+          <a:ln w="12700">
+            <a:solidFill>
+              <a:srgbClr val="D5DFE1"/>
+            </a:solidFill>
+            <a:prstDash val="solid"/>
+          </a:ln>
+          <a:effectLst>
+            <a:outerShdw sx="100000" sy="100000" kx="0" ky="0" algn="bl" rotWithShape="0" blurRad="76200" dist="25400" dir="5400000">
+              <a:srgbClr val="AEB9BD">
+                <a:alpha val="25000"/>
+              </a:srgbClr>
+            </a:outerShdw>
+          </a:effectLst>
+        </p:spPr>
+      </p:sp>
+      <p:sp>
+        <p:nvSpPr>
           <p:cNvPr id="7" name="Text 5"/>
           <p:cNvSpPr/>
           <p:nvPr/>
         </p:nvSpPr>
         <p:spPr>
           <a:xfrm>
-            <a:off x="576072" y="3017520"/>
-            <a:ext cx="768096" cy="768096"/>
-          </a:xfrm>
-          <a:prstGeom prst="rect">
-            <a:avLst/>
-          </a:prstGeom>
-          <a:noFill/>
-          <a:ln/>
-        </p:spPr>
-        <p:txBody>
-          <a:bodyPr wrap="square" lIns="0" tIns="0" rIns="0" bIns="0" rtlCol="0" anchor="ctr"/>
-          <a:lstStyle/>
-          <a:p>
-            <a:pPr algn="ctr" indent="0" marL="0">
-              <a:buNone/>
-            </a:pPr>
-            <a:r>
-              <a:rPr lang="en-US" sz="2200" b="1" dirty="0">
-                <a:solidFill>
-                  <a:srgbClr val="FFFFFF"/>
+            <a:off x="777240" y="2221992"/>
+            <a:ext cx="777240" cy="914400"/>
+          </a:xfrm>
+          <a:prstGeom prst="rect">
+            <a:avLst/>
+          </a:prstGeom>
+          <a:noFill/>
+          <a:ln/>
+        </p:spPr>
+        <p:txBody>
+          <a:bodyPr wrap="square" lIns="0" tIns="0" rIns="0" bIns="0" rtlCol="0" anchor="ctr"/>
+          <a:lstStyle/>
+          <a:p>
+            <a:pPr indent="0" marL="0">
+              <a:buNone/>
+            </a:pPr>
+            <a:r>
+              <a:rPr lang="en-US" sz="2600" b="1" dirty="0">
+                <a:solidFill>
+                  <a:srgbClr val="2E6E6E"/>
                 </a:solidFill>
                 <a:latin typeface="Cambria" pitchFamily="34" charset="0"/>
                 <a:ea typeface="Cambria" pitchFamily="34" charset="-122"/>
                 <a:cs typeface="Cambria" pitchFamily="34" charset="-120"/>
               </a:rPr>
-              <a:t>We</a:t>
-            </a:r>
-            <a:endParaRPr lang="en-US" sz="2200" dirty="0"/>
+              <a:t>Q2</a:t>
+            </a:r>
+            <a:endParaRPr lang="en-US" sz="2600" dirty="0"/>
           </a:p>
         </p:txBody>
       </p:sp>
@@ -4185,136 +4255,143 @@
         </p:nvSpPr>
         <p:spPr>
           <a:xfrm>
-            <a:off x="2404872" y="3017520"/>
-            <a:ext cx="768096" cy="768096"/>
-          </a:xfrm>
-          <a:prstGeom prst="rect">
-            <a:avLst/>
-          </a:prstGeom>
-          <a:noFill/>
-          <a:ln/>
-        </p:spPr>
-        <p:txBody>
-          <a:bodyPr wrap="square" lIns="0" tIns="0" rIns="0" bIns="0" rtlCol="0" anchor="ctr"/>
-          <a:lstStyle/>
-          <a:p>
-            <a:pPr algn="ctr" indent="0" marL="0">
-              <a:buNone/>
-            </a:pPr>
-            <a:r>
-              <a:rPr lang="en-US" sz="2200" b="1" dirty="0">
-                <a:solidFill>
-                  <a:srgbClr val="FFFFFF"/>
+            <a:off x="1691640" y="2350008"/>
+            <a:ext cx="6766560" cy="685800"/>
+          </a:xfrm>
+          <a:prstGeom prst="rect">
+            <a:avLst/>
+          </a:prstGeom>
+          <a:noFill/>
+          <a:ln/>
+        </p:spPr>
+        <p:txBody>
+          <a:bodyPr wrap="square" lIns="0" tIns="0" rIns="0" bIns="0" rtlCol="0" anchor="ctr"/>
+          <a:lstStyle/>
+          <a:p>
+            <a:pPr indent="0" marL="0">
+              <a:lnSpc>
+                <a:spcPct val="112000"/>
+              </a:lnSpc>
+              <a:buNone/>
+            </a:pPr>
+            <a:r>
+              <a:rPr lang="en-US" sz="1700" b="1" dirty="0">
+                <a:solidFill>
+                  <a:srgbClr val="22313D"/>
+                </a:solidFill>
+                <a:latin typeface="Calibri" pitchFamily="34" charset="0"/>
+                <a:ea typeface="Calibri" pitchFamily="34" charset="-122"/>
+                <a:cs typeface="Calibri" pitchFamily="34" charset="-120"/>
+              </a:rPr>
+              <a:t>Who deserves a goodbye?</a:t>
+            </a:r>
+            <a:endParaRPr lang="en-US" sz="1700" dirty="0"/>
+          </a:p>
+          <a:p>
+            <a:pPr indent="0" marL="0">
+              <a:lnSpc>
+                <a:spcPct val="112000"/>
+              </a:lnSpc>
+              <a:buNone/>
+            </a:pPr>
+            <a:r>
+              <a:rPr lang="en-US" sz="1150" dirty="0">
+                <a:solidFill>
+                  <a:srgbClr val="888888"/>
+                </a:solidFill>
+                <a:latin typeface="Calibri" pitchFamily="34" charset="0"/>
+                <a:ea typeface="Calibri" pitchFamily="34" charset="-122"/>
+                <a:cs typeface="Calibri" pitchFamily="34" charset="-120"/>
+              </a:rPr>
+              <a:t>The community behind 50 years of relationships. Answered by the Season of Listening.</a:t>
+            </a:r>
+            <a:endParaRPr lang="en-US" sz="1700" dirty="0"/>
+          </a:p>
+        </p:txBody>
+      </p:sp>
+      <p:sp>
+        <p:nvSpPr>
+          <p:cNvPr id="9" name="Shape 7"/>
+          <p:cNvSpPr/>
+          <p:nvPr/>
+        </p:nvSpPr>
+        <p:spPr>
+          <a:xfrm>
+            <a:off x="502920" y="3300984"/>
+            <a:ext cx="8138160" cy="914400"/>
+          </a:xfrm>
+          <a:prstGeom prst="roundRect">
+            <a:avLst>
+              <a:gd name="adj" fmla="val 9000"/>
+            </a:avLst>
+          </a:prstGeom>
+          <a:solidFill>
+            <a:srgbClr val="FFFFFF"/>
+          </a:solidFill>
+          <a:ln w="12700">
+            <a:solidFill>
+              <a:srgbClr val="D5DFE1"/>
+            </a:solidFill>
+            <a:prstDash val="solid"/>
+          </a:ln>
+          <a:effectLst>
+            <a:outerShdw sx="100000" sy="100000" kx="0" ky="0" algn="bl" rotWithShape="0" blurRad="76200" dist="25400" dir="5400000">
+              <a:srgbClr val="AEB9BD">
+                <a:alpha val="25000"/>
+              </a:srgbClr>
+            </a:outerShdw>
+          </a:effectLst>
+        </p:spPr>
+      </p:sp>
+      <p:sp>
+        <p:nvSpPr>
+          <p:cNvPr id="10" name="Text 8"/>
+          <p:cNvSpPr/>
+          <p:nvPr/>
+        </p:nvSpPr>
+        <p:spPr>
+          <a:xfrm>
+            <a:off x="777240" y="3300984"/>
+            <a:ext cx="777240" cy="914400"/>
+          </a:xfrm>
+          <a:prstGeom prst="rect">
+            <a:avLst/>
+          </a:prstGeom>
+          <a:noFill/>
+          <a:ln/>
+        </p:spPr>
+        <p:txBody>
+          <a:bodyPr wrap="square" lIns="0" tIns="0" rIns="0" bIns="0" rtlCol="0" anchor="ctr"/>
+          <a:lstStyle/>
+          <a:p>
+            <a:pPr indent="0" marL="0">
+              <a:buNone/>
+            </a:pPr>
+            <a:r>
+              <a:rPr lang="en-US" sz="2600" b="1" dirty="0">
+                <a:solidFill>
+                  <a:srgbClr val="1F3A4D"/>
                 </a:solidFill>
                 <a:latin typeface="Cambria" pitchFamily="34" charset="0"/>
                 <a:ea typeface="Cambria" pitchFamily="34" charset="-122"/>
                 <a:cs typeface="Cambria" pitchFamily="34" charset="-120"/>
               </a:rPr>
-              <a:t>It</a:t>
-            </a:r>
-            <a:endParaRPr lang="en-US" sz="2200" dirty="0"/>
-          </a:p>
-        </p:txBody>
-      </p:sp>
-      <p:sp>
-        <p:nvSpPr>
-          <p:cNvPr id="9" name="Shape 7"/>
-          <p:cNvSpPr/>
-          <p:nvPr/>
-        </p:nvSpPr>
-        <p:spPr>
-          <a:xfrm>
-            <a:off x="1307592" y="2130552"/>
-            <a:ext cx="-256032" cy="841248"/>
-          </a:xfrm>
-          <a:prstGeom prst="line">
-            <a:avLst/>
-          </a:prstGeom>
-          <a:noFill/>
-          <a:ln w="22225">
-            <a:solidFill>
-              <a:srgbClr val="888888"/>
-            </a:solidFill>
-            <a:prstDash val="solid"/>
-          </a:ln>
-        </p:spPr>
-      </p:sp>
-      <p:sp>
-        <p:nvSpPr>
-          <p:cNvPr id="10" name="Shape 8"/>
-          <p:cNvSpPr/>
-          <p:nvPr/>
-        </p:nvSpPr>
-        <p:spPr>
-          <a:xfrm>
-            <a:off x="2441448" y="2130552"/>
-            <a:ext cx="256032" cy="841248"/>
-          </a:xfrm>
-          <a:prstGeom prst="line">
-            <a:avLst/>
-          </a:prstGeom>
-          <a:noFill/>
-          <a:ln w="22225">
-            <a:solidFill>
-              <a:srgbClr val="888888"/>
-            </a:solidFill>
-            <a:prstDash val="solid"/>
-          </a:ln>
-        </p:spPr>
-      </p:sp>
-      <p:sp>
-        <p:nvSpPr>
-          <p:cNvPr id="11" name="Shape 9"/>
-          <p:cNvSpPr/>
-          <p:nvPr/>
-        </p:nvSpPr>
-        <p:spPr>
-          <a:xfrm>
-            <a:off x="1399032" y="3401568"/>
-            <a:ext cx="950976" cy="0"/>
-          </a:xfrm>
-          <a:prstGeom prst="line">
-            <a:avLst/>
-          </a:prstGeom>
-          <a:noFill/>
-          <a:ln w="22225">
-            <a:solidFill>
-              <a:srgbClr val="888888"/>
-            </a:solidFill>
-            <a:prstDash val="solid"/>
-          </a:ln>
-        </p:spPr>
-      </p:sp>
-      <p:sp>
-        <p:nvSpPr>
-          <p:cNvPr id="12" name="Shape 10"/>
-          <p:cNvSpPr/>
-          <p:nvPr/>
-        </p:nvSpPr>
-        <p:spPr>
-          <a:xfrm>
-            <a:off x="3977640" y="1344168"/>
-            <a:ext cx="274320" cy="274320"/>
-          </a:xfrm>
-          <a:prstGeom prst="ellipse">
-            <a:avLst/>
-          </a:prstGeom>
-          <a:solidFill>
-            <a:srgbClr val="1F3A4D"/>
-          </a:solidFill>
-          <a:ln/>
-        </p:spPr>
-      </p:sp>
-      <p:sp>
-        <p:nvSpPr>
-          <p:cNvPr id="13" name="Text 11"/>
-          <p:cNvSpPr/>
-          <p:nvPr/>
-        </p:nvSpPr>
-        <p:spPr>
-          <a:xfrm>
-            <a:off x="4434840" y="1207008"/>
-            <a:ext cx="4206240" cy="914400"/>
+              <a:t>Q3</a:t>
+            </a:r>
+            <a:endParaRPr lang="en-US" sz="2600" dirty="0"/>
+          </a:p>
+        </p:txBody>
+      </p:sp>
+      <p:sp>
+        <p:nvSpPr>
+          <p:cNvPr id="11" name="Text 9"/>
+          <p:cNvSpPr/>
+          <p:nvPr/>
+        </p:nvSpPr>
+        <p:spPr>
+          <a:xfrm>
+            <a:off x="1691640" y="3429000"/>
+            <a:ext cx="6766560" cy="685800"/>
           </a:xfrm>
           <a:prstGeom prst="rect">
             <a:avLst/>
@@ -4328,212 +4405,48 @@
           <a:p>
             <a:pPr indent="0" marL="0">
               <a:lnSpc>
-                <a:spcPct val="108000"/>
+                <a:spcPct val="112000"/>
               </a:lnSpc>
               <a:buNone/>
             </a:pPr>
             <a:r>
-              <a:rPr lang="en-US" sz="1550" b="1" dirty="0">
-                <a:solidFill>
-                  <a:srgbClr val="1F3A4D"/>
-                </a:solidFill>
-                <a:latin typeface="Calibri" pitchFamily="34" charset="0"/>
-                <a:ea typeface="Calibri" pitchFamily="34" charset="-122"/>
-                <a:cs typeface="Calibri" pitchFamily="34" charset="-120"/>
-              </a:rPr>
-              <a:t>I — the leader</a:t>
-            </a:r>
-            <a:endParaRPr lang="en-US" sz="1550" dirty="0"/>
+              <a:rPr lang="en-US" sz="1700" b="1" dirty="0">
+                <a:solidFill>
+                  <a:srgbClr val="22313D"/>
+                </a:solidFill>
+                <a:latin typeface="Calibri" pitchFamily="34" charset="0"/>
+                <a:ea typeface="Calibri" pitchFamily="34" charset="-122"/>
+                <a:cs typeface="Calibri" pitchFamily="34" charset="-120"/>
+              </a:rPr>
+              <a:t>What lives on?</a:t>
+            </a:r>
+            <a:endParaRPr lang="en-US" sz="1700" dirty="0"/>
           </a:p>
           <a:p>
             <a:pPr indent="0" marL="0">
               <a:lnSpc>
-                <a:spcPct val="108000"/>
+                <a:spcPct val="112000"/>
               </a:lnSpc>
               <a:buNone/>
             </a:pPr>
             <a:r>
-              <a:rPr lang="en-US" sz="1250" dirty="0">
-                <a:solidFill>
-                  <a:srgbClr val="22313D"/>
-                </a:solidFill>
-                <a:latin typeface="Calibri" pitchFamily="34" charset="0"/>
-                <a:ea typeface="Calibri" pitchFamily="34" charset="-122"/>
-                <a:cs typeface="Calibri" pitchFamily="34" charset="-120"/>
-              </a:rPr>
-              <a:t>Succession, identity, letting go. Someone has to own the ending.</a:t>
-            </a:r>
-            <a:endParaRPr lang="en-US" sz="1550" dirty="0"/>
-          </a:p>
-        </p:txBody>
-      </p:sp>
-      <p:sp>
-        <p:nvSpPr>
-          <p:cNvPr id="14" name="Shape 12"/>
-          <p:cNvSpPr/>
-          <p:nvPr/>
-        </p:nvSpPr>
-        <p:spPr>
-          <a:xfrm>
-            <a:off x="3977640" y="2331720"/>
-            <a:ext cx="274320" cy="274320"/>
-          </a:xfrm>
-          <a:prstGeom prst="ellipse">
-            <a:avLst/>
-          </a:prstGeom>
-          <a:solidFill>
-            <a:srgbClr val="2E6E6E"/>
-          </a:solidFill>
-          <a:ln/>
-        </p:spPr>
-      </p:sp>
-      <p:sp>
-        <p:nvSpPr>
-          <p:cNvPr id="15" name="Text 13"/>
-          <p:cNvSpPr/>
-          <p:nvPr/>
-        </p:nvSpPr>
-        <p:spPr>
-          <a:xfrm>
-            <a:off x="4434840" y="2194560"/>
-            <a:ext cx="4206240" cy="914400"/>
-          </a:xfrm>
-          <a:prstGeom prst="rect">
-            <a:avLst/>
-          </a:prstGeom>
-          <a:noFill/>
-          <a:ln/>
-        </p:spPr>
-        <p:txBody>
-          <a:bodyPr wrap="square" lIns="0" tIns="0" rIns="0" bIns="0" rtlCol="0" anchor="ctr"/>
-          <a:lstStyle/>
-          <a:p>
-            <a:pPr indent="0" marL="0">
-              <a:lnSpc>
-                <a:spcPct val="108000"/>
-              </a:lnSpc>
-              <a:buNone/>
-            </a:pPr>
-            <a:r>
-              <a:rPr lang="en-US" sz="1550" b="1" dirty="0">
-                <a:solidFill>
-                  <a:srgbClr val="2E6E6E"/>
-                </a:solidFill>
-                <a:latin typeface="Calibri" pitchFamily="34" charset="0"/>
-                <a:ea typeface="Calibri" pitchFamily="34" charset="-122"/>
-                <a:cs typeface="Calibri" pitchFamily="34" charset="-120"/>
-              </a:rPr>
-              <a:t>We — the community</a:t>
-            </a:r>
-            <a:endParaRPr lang="en-US" sz="1550" dirty="0"/>
-          </a:p>
-          <a:p>
-            <a:pPr indent="0" marL="0">
-              <a:lnSpc>
-                <a:spcPct val="108000"/>
-              </a:lnSpc>
-              <a:buNone/>
-            </a:pPr>
-            <a:r>
-              <a:rPr lang="en-US" sz="1250" dirty="0">
-                <a:solidFill>
-                  <a:srgbClr val="22313D"/>
-                </a:solidFill>
-                <a:latin typeface="Calibri" pitchFamily="34" charset="0"/>
-                <a:ea typeface="Calibri" pitchFamily="34" charset="-122"/>
-                <a:cs typeface="Calibri" pitchFamily="34" charset="-120"/>
-              </a:rPr>
-              <a:t>Being heard before goodbye. Listening as infrastructure, not sentiment.</a:t>
-            </a:r>
-            <a:endParaRPr lang="en-US" sz="1550" dirty="0"/>
-          </a:p>
-        </p:txBody>
-      </p:sp>
-      <p:sp>
-        <p:nvSpPr>
-          <p:cNvPr id="16" name="Shape 14"/>
-          <p:cNvSpPr/>
-          <p:nvPr/>
-        </p:nvSpPr>
-        <p:spPr>
-          <a:xfrm>
-            <a:off x="3977640" y="3319272"/>
-            <a:ext cx="274320" cy="274320"/>
-          </a:xfrm>
-          <a:prstGeom prst="ellipse">
-            <a:avLst/>
-          </a:prstGeom>
-          <a:solidFill>
-            <a:srgbClr val="C08A2E"/>
-          </a:solidFill>
-          <a:ln/>
-        </p:spPr>
-      </p:sp>
-      <p:sp>
-        <p:nvSpPr>
-          <p:cNvPr id="17" name="Text 15"/>
-          <p:cNvSpPr/>
-          <p:nvPr/>
-        </p:nvSpPr>
-        <p:spPr>
-          <a:xfrm>
-            <a:off x="4434840" y="3182112"/>
-            <a:ext cx="4206240" cy="914400"/>
-          </a:xfrm>
-          <a:prstGeom prst="rect">
-            <a:avLst/>
-          </a:prstGeom>
-          <a:noFill/>
-          <a:ln/>
-        </p:spPr>
-        <p:txBody>
-          <a:bodyPr wrap="square" lIns="0" tIns="0" rIns="0" bIns="0" rtlCol="0" anchor="ctr"/>
-          <a:lstStyle/>
-          <a:p>
-            <a:pPr indent="0" marL="0">
-              <a:lnSpc>
-                <a:spcPct val="108000"/>
-              </a:lnSpc>
-              <a:buNone/>
-            </a:pPr>
-            <a:r>
-              <a:rPr lang="en-US" sz="1550" b="1" dirty="0">
-                <a:solidFill>
-                  <a:srgbClr val="C08A2E"/>
-                </a:solidFill>
-                <a:latin typeface="Calibri" pitchFamily="34" charset="0"/>
-                <a:ea typeface="Calibri" pitchFamily="34" charset="-122"/>
-                <a:cs typeface="Calibri" pitchFamily="34" charset="-120"/>
-              </a:rPr>
-              <a:t>It — the systems</a:t>
-            </a:r>
-            <a:endParaRPr lang="en-US" sz="1550" dirty="0"/>
-          </a:p>
-          <a:p>
-            <a:pPr indent="0" marL="0">
-              <a:lnSpc>
-                <a:spcPct val="108000"/>
-              </a:lnSpc>
-              <a:buNone/>
-            </a:pPr>
-            <a:r>
-              <a:rPr lang="en-US" sz="1250" dirty="0">
-                <a:solidFill>
-                  <a:srgbClr val="22313D"/>
-                </a:solidFill>
-                <a:latin typeface="Calibri" pitchFamily="34" charset="0"/>
-                <a:ea typeface="Calibri" pitchFamily="34" charset="-122"/>
-                <a:cs typeface="Calibri" pitchFamily="34" charset="-120"/>
-              </a:rPr>
-              <a:t>Data, money, tech. Institutional memory is a systems problem.</a:t>
-            </a:r>
-            <a:endParaRPr lang="en-US" sz="1550" dirty="0"/>
-          </a:p>
-        </p:txBody>
-      </p:sp>
-      <p:sp>
-        <p:nvSpPr>
-          <p:cNvPr id="18" name="Text 16"/>
+              <a:rPr lang="en-US" sz="1150" dirty="0">
+                <a:solidFill>
+                  <a:srgbClr val="888888"/>
+                </a:solidFill>
+                <a:latin typeface="Calibri" pitchFamily="34" charset="0"/>
+                <a:ea typeface="Calibri" pitchFamily="34" charset="-122"/>
+                <a:cs typeface="Calibri" pitchFamily="34" charset="-120"/>
+              </a:rPr>
+              <a:t>The mission, the stories, the assets. Answered by the legacy plan — and a celebration.</a:t>
+            </a:r>
+            <a:endParaRPr lang="en-US" sz="1700" dirty="0"/>
+          </a:p>
+        </p:txBody>
+      </p:sp>
+      <p:sp>
+        <p:nvSpPr>
+          <p:cNvPr id="12" name="Text 10"/>
           <p:cNvSpPr/>
           <p:nvPr/>
         </p:nvSpPr>
@@ -4564,7 +4477,7 @@
                 <a:ea typeface="Calibri" pitchFamily="34" charset="-122"/>
                 <a:cs typeface="Calibri" pitchFamily="34" charset="-120"/>
               </a:rPr>
-              <a:t>Transitions fail when you optimize one dimension and neglect the other two.</a:t>
+              <a:t>Transitions fail when you answer one question and skip the other two.</a:t>
             </a:r>
             <a:endParaRPr lang="en-US" sz="1350" dirty="0"/>
           </a:p>
@@ -4635,7 +4548,7 @@
                 <a:ea typeface="Cambria" pitchFamily="34" charset="-122"/>
                 <a:cs typeface="Cambria" pitchFamily="34" charset="-120"/>
               </a:rPr>
-              <a:t>It — forensic reconstruction</a:t>
+              <a:t>What do we actually have?</a:t>
             </a:r>
             <a:endParaRPr lang="en-US" sz="3000" dirty="0"/>
           </a:p>
@@ -4643,110 +4556,85 @@
       </p:sp>
       <p:sp>
         <p:nvSpPr>
-          <p:cNvPr id="3" name="Shape 1"/>
-          <p:cNvSpPr/>
-          <p:nvPr/>
-        </p:nvSpPr>
-        <p:spPr>
-          <a:xfrm>
-            <a:off x="8403336" y="82296"/>
-            <a:ext cx="164592" cy="164592"/>
-          </a:xfrm>
-          <a:prstGeom prst="ellipse">
-            <a:avLst/>
-          </a:prstGeom>
-          <a:solidFill>
-            <a:srgbClr val="1F3A4D">
-              <a:alpha val="35000"/>
-            </a:srgbClr>
-          </a:solidFill>
-          <a:ln/>
-        </p:spPr>
-      </p:sp>
-      <p:sp>
-        <p:nvSpPr>
-          <p:cNvPr id="4" name="Shape 2"/>
-          <p:cNvSpPr/>
-          <p:nvPr/>
-        </p:nvSpPr>
-        <p:spPr>
-          <a:xfrm>
-            <a:off x="8212409" y="411480"/>
-            <a:ext cx="164592" cy="164592"/>
-          </a:xfrm>
-          <a:prstGeom prst="ellipse">
-            <a:avLst/>
-          </a:prstGeom>
-          <a:solidFill>
-            <a:srgbClr val="2E6E6E">
-              <a:alpha val="35000"/>
-            </a:srgbClr>
-          </a:solidFill>
-          <a:ln/>
-        </p:spPr>
+          <p:cNvPr id="3" name="Text 1"/>
+          <p:cNvSpPr/>
+          <p:nvPr/>
+        </p:nvSpPr>
+        <p:spPr>
+          <a:xfrm>
+            <a:off x="7726680" y="237744"/>
+            <a:ext cx="960120" cy="402336"/>
+          </a:xfrm>
+          <a:prstGeom prst="rect">
+            <a:avLst/>
+          </a:prstGeom>
+          <a:noFill/>
+          <a:ln/>
+        </p:spPr>
+        <p:txBody>
+          <a:bodyPr wrap="square" lIns="0" tIns="0" rIns="0" bIns="0" rtlCol="0" anchor="ctr"/>
+          <a:lstStyle/>
+          <a:p>
+            <a:pPr algn="r" indent="0" marL="0">
+              <a:buNone/>
+            </a:pPr>
+            <a:r>
+              <a:rPr lang="en-US" sz="2400" b="1" dirty="0">
+                <a:solidFill>
+                  <a:srgbClr val="C08A2E"/>
+                </a:solidFill>
+                <a:latin typeface="Cambria" pitchFamily="34" charset="0"/>
+                <a:ea typeface="Cambria" pitchFamily="34" charset="-122"/>
+                <a:cs typeface="Cambria" pitchFamily="34" charset="-120"/>
+              </a:rPr>
+              <a:t>Q1</a:t>
+            </a:r>
+            <a:endParaRPr lang="en-US" sz="2400" dirty="0"/>
+          </a:p>
+        </p:txBody>
+      </p:sp>
+      <p:sp>
+        <p:nvSpPr>
+          <p:cNvPr id="4" name="Text 2"/>
+          <p:cNvSpPr/>
+          <p:nvPr/>
+        </p:nvSpPr>
+        <p:spPr>
+          <a:xfrm>
+            <a:off x="6675120" y="640080"/>
+            <a:ext cx="2011680" cy="201168"/>
+          </a:xfrm>
+          <a:prstGeom prst="rect">
+            <a:avLst/>
+          </a:prstGeom>
+          <a:noFill/>
+          <a:ln/>
+        </p:spPr>
+        <p:txBody>
+          <a:bodyPr wrap="square" lIns="0" tIns="0" rIns="0" bIns="0" rtlCol="0" anchor="ctr"/>
+          <a:lstStyle/>
+          <a:p>
+            <a:pPr algn="r" indent="0" marL="0">
+              <a:buNone/>
+            </a:pPr>
+            <a:r>
+              <a:rPr lang="en-US" sz="900" b="1" spc="200" kern="0" dirty="0">
+                <a:solidFill>
+                  <a:srgbClr val="888888"/>
+                </a:solidFill>
+                <a:latin typeface="Calibri" pitchFamily="34" charset="0"/>
+                <a:ea typeface="Calibri" pitchFamily="34" charset="-122"/>
+                <a:cs typeface="Calibri" pitchFamily="34" charset="-120"/>
+              </a:rPr>
+              <a:t>THE SYSTEMS</a:t>
+            </a:r>
+            <a:endParaRPr lang="en-US" sz="900" dirty="0"/>
+          </a:p>
+        </p:txBody>
       </p:sp>
       <p:sp>
         <p:nvSpPr>
           <p:cNvPr id="5" name="Shape 3"/>
-          <p:cNvSpPr/>
-          <p:nvPr/>
-        </p:nvSpPr>
-        <p:spPr>
-          <a:xfrm>
-            <a:off x="8553115" y="370332"/>
-            <a:ext cx="246888" cy="246888"/>
-          </a:xfrm>
-          <a:prstGeom prst="ellipse">
-            <a:avLst/>
-          </a:prstGeom>
-          <a:solidFill>
-            <a:srgbClr val="C08A2E"/>
-          </a:solidFill>
-          <a:ln/>
-        </p:spPr>
-      </p:sp>
-      <p:sp>
-        <p:nvSpPr>
-          <p:cNvPr id="6" name="Text 4"/>
-          <p:cNvSpPr/>
-          <p:nvPr/>
-        </p:nvSpPr>
-        <p:spPr>
-          <a:xfrm>
-            <a:off x="8028432" y="658368"/>
-            <a:ext cx="914400" cy="201168"/>
-          </a:xfrm>
-          <a:prstGeom prst="rect">
-            <a:avLst/>
-          </a:prstGeom>
-          <a:noFill/>
-          <a:ln/>
-        </p:spPr>
-        <p:txBody>
-          <a:bodyPr wrap="square" rtlCol="0" anchor="ctr"/>
-          <a:lstStyle/>
-          <a:p>
-            <a:pPr algn="ctr" indent="0" marL="0">
-              <a:buNone/>
-            </a:pPr>
-            <a:r>
-              <a:rPr lang="en-US" sz="900" b="1" spc="200" kern="0" dirty="0">
-                <a:solidFill>
-                  <a:srgbClr val="C08A2E"/>
-                </a:solidFill>
-                <a:latin typeface="Calibri" pitchFamily="34" charset="0"/>
-                <a:ea typeface="Calibri" pitchFamily="34" charset="-122"/>
-                <a:cs typeface="Calibri" pitchFamily="34" charset="-120"/>
-              </a:rPr>
-              <a:t>It</a:t>
-            </a:r>
-            <a:endParaRPr lang="en-US" sz="900" dirty="0"/>
-          </a:p>
-        </p:txBody>
-      </p:sp>
-      <p:sp>
-        <p:nvSpPr>
-          <p:cNvPr id="7" name="Shape 5"/>
           <p:cNvSpPr/>
           <p:nvPr/>
         </p:nvSpPr>
@@ -4773,7 +4661,7 @@
       </p:sp>
       <p:sp>
         <p:nvSpPr>
-          <p:cNvPr id="8" name="Text 6"/>
+          <p:cNvPr id="6" name="Text 4"/>
           <p:cNvSpPr/>
           <p:nvPr/>
         </p:nvSpPr>
@@ -4812,7 +4700,7 @@
       </p:sp>
       <p:sp>
         <p:nvSpPr>
-          <p:cNvPr id="9" name="Text 7"/>
+          <p:cNvPr id="7" name="Text 5"/>
           <p:cNvSpPr/>
           <p:nvPr/>
         </p:nvSpPr>
@@ -4848,7 +4736,7 @@
       </p:sp>
       <p:sp>
         <p:nvSpPr>
-          <p:cNvPr id="10" name="Shape 8"/>
+          <p:cNvPr id="8" name="Shape 6"/>
           <p:cNvSpPr/>
           <p:nvPr/>
         </p:nvSpPr>
@@ -4875,7 +4763,7 @@
       </p:sp>
       <p:sp>
         <p:nvSpPr>
-          <p:cNvPr id="11" name="Text 9"/>
+          <p:cNvPr id="9" name="Text 7"/>
           <p:cNvSpPr/>
           <p:nvPr/>
         </p:nvSpPr>
@@ -4914,7 +4802,7 @@
       </p:sp>
       <p:sp>
         <p:nvSpPr>
-          <p:cNvPr id="12" name="Text 10"/>
+          <p:cNvPr id="10" name="Text 8"/>
           <p:cNvSpPr/>
           <p:nvPr/>
         </p:nvSpPr>
@@ -4950,7 +4838,7 @@
       </p:sp>
       <p:sp>
         <p:nvSpPr>
-          <p:cNvPr id="13" name="Shape 11"/>
+          <p:cNvPr id="11" name="Shape 9"/>
           <p:cNvSpPr/>
           <p:nvPr/>
         </p:nvSpPr>
@@ -4977,7 +4865,7 @@
       </p:sp>
       <p:sp>
         <p:nvSpPr>
-          <p:cNvPr id="14" name="Text 12"/>
+          <p:cNvPr id="12" name="Text 10"/>
           <p:cNvSpPr/>
           <p:nvPr/>
         </p:nvSpPr>
@@ -5016,7 +4904,7 @@
       </p:sp>
       <p:sp>
         <p:nvSpPr>
-          <p:cNvPr id="15" name="Text 13"/>
+          <p:cNvPr id="13" name="Text 11"/>
           <p:cNvSpPr/>
           <p:nvPr/>
         </p:nvSpPr>
@@ -5052,7 +4940,7 @@
       </p:sp>
       <p:sp>
         <p:nvSpPr>
-          <p:cNvPr id="16" name="Shape 14"/>
+          <p:cNvPr id="14" name="Shape 12"/>
           <p:cNvSpPr/>
           <p:nvPr/>
         </p:nvSpPr>
@@ -5079,7 +4967,7 @@
       </p:sp>
       <p:sp>
         <p:nvSpPr>
-          <p:cNvPr id="17" name="Text 15"/>
+          <p:cNvPr id="15" name="Text 13"/>
           <p:cNvSpPr/>
           <p:nvPr/>
         </p:nvSpPr>
@@ -5118,7 +5006,7 @@
       </p:sp>
       <p:sp>
         <p:nvSpPr>
-          <p:cNvPr id="18" name="Text 16"/>
+          <p:cNvPr id="16" name="Text 14"/>
           <p:cNvSpPr/>
           <p:nvPr/>
         </p:nvSpPr>
@@ -5154,7 +5042,7 @@
       </p:sp>
       <p:sp>
         <p:nvSpPr>
-          <p:cNvPr id="19" name="Shape 17"/>
+          <p:cNvPr id="17" name="Shape 15"/>
           <p:cNvSpPr/>
           <p:nvPr/>
         </p:nvSpPr>
@@ -5181,7 +5069,7 @@
       </p:sp>
       <p:sp>
         <p:nvSpPr>
-          <p:cNvPr id="20" name="Text 18"/>
+          <p:cNvPr id="18" name="Text 16"/>
           <p:cNvSpPr/>
           <p:nvPr/>
         </p:nvSpPr>
@@ -5220,7 +5108,7 @@
       </p:sp>
       <p:sp>
         <p:nvSpPr>
-          <p:cNvPr id="21" name="Shape 19"/>
+          <p:cNvPr id="19" name="Shape 17"/>
           <p:cNvSpPr/>
           <p:nvPr/>
         </p:nvSpPr>
@@ -5242,7 +5130,7 @@
       </p:sp>
       <p:sp>
         <p:nvSpPr>
-          <p:cNvPr id="22" name="Text 20"/>
+          <p:cNvPr id="20" name="Text 18"/>
           <p:cNvSpPr/>
           <p:nvPr/>
         </p:nvSpPr>
@@ -5304,7 +5192,7 @@
       </p:sp>
       <p:sp>
         <p:nvSpPr>
-          <p:cNvPr id="23" name="Shape 21"/>
+          <p:cNvPr id="21" name="Shape 19"/>
           <p:cNvSpPr/>
           <p:nvPr/>
         </p:nvSpPr>
@@ -5326,7 +5214,7 @@
       </p:sp>
       <p:sp>
         <p:nvSpPr>
-          <p:cNvPr id="24" name="Text 22"/>
+          <p:cNvPr id="22" name="Text 20"/>
           <p:cNvSpPr/>
           <p:nvPr/>
         </p:nvSpPr>
@@ -5388,7 +5276,7 @@
       </p:sp>
       <p:sp>
         <p:nvSpPr>
-          <p:cNvPr id="25" name="Shape 23"/>
+          <p:cNvPr id="23" name="Shape 21"/>
           <p:cNvSpPr/>
           <p:nvPr/>
         </p:nvSpPr>
@@ -5410,7 +5298,7 @@
       </p:sp>
       <p:sp>
         <p:nvSpPr>
-          <p:cNvPr id="26" name="Text 24"/>
+          <p:cNvPr id="24" name="Text 22"/>
           <p:cNvSpPr/>
           <p:nvPr/>
         </p:nvSpPr>
@@ -5472,7 +5360,7 @@
       </p:sp>
       <p:sp>
         <p:nvSpPr>
-          <p:cNvPr id="27" name="Text 25"/>
+          <p:cNvPr id="25" name="Text 23"/>
           <p:cNvSpPr/>
           <p:nvPr/>
         </p:nvSpPr>
@@ -5539,7 +5427,7 @@
       </p:sp>
       <p:sp>
         <p:nvSpPr>
-          <p:cNvPr id="28" name="Text 26"/>
+          <p:cNvPr id="26" name="Text 24"/>
           <p:cNvSpPr/>
           <p:nvPr/>
         </p:nvSpPr>
@@ -5641,7 +5529,7 @@
                 <a:ea typeface="Cambria" pitchFamily="34" charset="-122"/>
                 <a:cs typeface="Cambria" pitchFamily="34" charset="-120"/>
               </a:rPr>
-              <a:t>We — the Season of Listening</a:t>
+              <a:t>Who deserves a goodbye?</a:t>
             </a:r>
             <a:endParaRPr lang="en-US" sz="3000" dirty="0"/>
           </a:p>
@@ -5649,102 +5537,77 @@
       </p:sp>
       <p:sp>
         <p:nvSpPr>
-          <p:cNvPr id="3" name="Shape 1"/>
-          <p:cNvSpPr/>
-          <p:nvPr/>
-        </p:nvSpPr>
-        <p:spPr>
-          <a:xfrm>
-            <a:off x="8403336" y="82296"/>
-            <a:ext cx="164592" cy="164592"/>
-          </a:xfrm>
-          <a:prstGeom prst="ellipse">
-            <a:avLst/>
-          </a:prstGeom>
-          <a:solidFill>
-            <a:srgbClr val="1F3A4D">
-              <a:alpha val="35000"/>
-            </a:srgbClr>
-          </a:solidFill>
-          <a:ln/>
-        </p:spPr>
-      </p:sp>
-      <p:sp>
-        <p:nvSpPr>
-          <p:cNvPr id="4" name="Shape 2"/>
-          <p:cNvSpPr/>
-          <p:nvPr/>
-        </p:nvSpPr>
-        <p:spPr>
-          <a:xfrm>
-            <a:off x="8171261" y="370332"/>
-            <a:ext cx="246888" cy="246888"/>
-          </a:xfrm>
-          <a:prstGeom prst="ellipse">
-            <a:avLst/>
-          </a:prstGeom>
-          <a:solidFill>
-            <a:srgbClr val="2E6E6E"/>
-          </a:solidFill>
-          <a:ln/>
-        </p:spPr>
-      </p:sp>
-      <p:sp>
-        <p:nvSpPr>
-          <p:cNvPr id="5" name="Shape 3"/>
-          <p:cNvSpPr/>
-          <p:nvPr/>
-        </p:nvSpPr>
-        <p:spPr>
-          <a:xfrm>
-            <a:off x="8594263" y="411480"/>
-            <a:ext cx="164592" cy="164592"/>
-          </a:xfrm>
-          <a:prstGeom prst="ellipse">
-            <a:avLst/>
-          </a:prstGeom>
-          <a:solidFill>
-            <a:srgbClr val="C08A2E">
-              <a:alpha val="35000"/>
-            </a:srgbClr>
-          </a:solidFill>
-          <a:ln/>
-        </p:spPr>
-      </p:sp>
-      <p:sp>
-        <p:nvSpPr>
-          <p:cNvPr id="6" name="Text 4"/>
-          <p:cNvSpPr/>
-          <p:nvPr/>
-        </p:nvSpPr>
-        <p:spPr>
-          <a:xfrm>
-            <a:off x="8028432" y="658368"/>
-            <a:ext cx="914400" cy="201168"/>
-          </a:xfrm>
-          <a:prstGeom prst="rect">
-            <a:avLst/>
-          </a:prstGeom>
-          <a:noFill/>
-          <a:ln/>
-        </p:spPr>
-        <p:txBody>
-          <a:bodyPr wrap="square" rtlCol="0" anchor="ctr"/>
-          <a:lstStyle/>
-          <a:p>
-            <a:pPr algn="ctr" indent="0" marL="0">
+          <p:cNvPr id="3" name="Text 1"/>
+          <p:cNvSpPr/>
+          <p:nvPr/>
+        </p:nvSpPr>
+        <p:spPr>
+          <a:xfrm>
+            <a:off x="7726680" y="237744"/>
+            <a:ext cx="960120" cy="402336"/>
+          </a:xfrm>
+          <a:prstGeom prst="rect">
+            <a:avLst/>
+          </a:prstGeom>
+          <a:noFill/>
+          <a:ln/>
+        </p:spPr>
+        <p:txBody>
+          <a:bodyPr wrap="square" lIns="0" tIns="0" rIns="0" bIns="0" rtlCol="0" anchor="ctr"/>
+          <a:lstStyle/>
+          <a:p>
+            <a:pPr algn="r" indent="0" marL="0">
+              <a:buNone/>
+            </a:pPr>
+            <a:r>
+              <a:rPr lang="en-US" sz="2400" b="1" dirty="0">
+                <a:solidFill>
+                  <a:srgbClr val="2E6E6E"/>
+                </a:solidFill>
+                <a:latin typeface="Cambria" pitchFamily="34" charset="0"/>
+                <a:ea typeface="Cambria" pitchFamily="34" charset="-122"/>
+                <a:cs typeface="Cambria" pitchFamily="34" charset="-120"/>
+              </a:rPr>
+              <a:t>Q2</a:t>
+            </a:r>
+            <a:endParaRPr lang="en-US" sz="2400" dirty="0"/>
+          </a:p>
+        </p:txBody>
+      </p:sp>
+      <p:sp>
+        <p:nvSpPr>
+          <p:cNvPr id="4" name="Text 2"/>
+          <p:cNvSpPr/>
+          <p:nvPr/>
+        </p:nvSpPr>
+        <p:spPr>
+          <a:xfrm>
+            <a:off x="6675120" y="640080"/>
+            <a:ext cx="2011680" cy="201168"/>
+          </a:xfrm>
+          <a:prstGeom prst="rect">
+            <a:avLst/>
+          </a:prstGeom>
+          <a:noFill/>
+          <a:ln/>
+        </p:spPr>
+        <p:txBody>
+          <a:bodyPr wrap="square" lIns="0" tIns="0" rIns="0" bIns="0" rtlCol="0" anchor="ctr"/>
+          <a:lstStyle/>
+          <a:p>
+            <a:pPr algn="r" indent="0" marL="0">
               <a:buNone/>
             </a:pPr>
             <a:r>
               <a:rPr lang="en-US" sz="900" b="1" spc="200" kern="0" dirty="0">
                 <a:solidFill>
-                  <a:srgbClr val="2E6E6E"/>
-                </a:solidFill>
-                <a:latin typeface="Calibri" pitchFamily="34" charset="0"/>
-                <a:ea typeface="Calibri" pitchFamily="34" charset="-122"/>
-                <a:cs typeface="Calibri" pitchFamily="34" charset="-120"/>
-              </a:rPr>
-              <a:t>We</a:t>
+                  <a:srgbClr val="888888"/>
+                </a:solidFill>
+                <a:latin typeface="Calibri" pitchFamily="34" charset="0"/>
+                <a:ea typeface="Calibri" pitchFamily="34" charset="-122"/>
+                <a:cs typeface="Calibri" pitchFamily="34" charset="-120"/>
+              </a:rPr>
+              <a:t>THE COMMUNITY</a:t>
             </a:r>
             <a:endParaRPr lang="en-US" sz="900" dirty="0"/>
           </a:p>
@@ -5752,7 +5615,7 @@
       </p:sp>
       <p:sp>
         <p:nvSpPr>
-          <p:cNvPr id="7" name="Text 5"/>
+          <p:cNvPr id="5" name="Text 3"/>
           <p:cNvSpPr/>
           <p:nvPr/>
         </p:nvSpPr>
@@ -5783,7 +5646,7 @@
                 <a:ea typeface="Calibri" pitchFamily="34" charset="-122"/>
                 <a:cs typeface="Calibri" pitchFamily="34" charset="-120"/>
               </a:rPr>
-              <a:t>The We: former retreatants — individuals, churches, organizations — plus volunteers, donors, staff, and board members.</a:t>
+              <a:t>The Season of Listening's answer: former retreatants — individuals, churches, organizations — plus volunteers, donors, staff, and board members.</a:t>
             </a:r>
             <a:endParaRPr lang="en-US" sz="1150" dirty="0"/>
           </a:p>
@@ -5791,7 +5654,7 @@
       </p:sp>
       <p:sp>
         <p:nvSpPr>
-          <p:cNvPr id="8" name="Text 6"/>
+          <p:cNvPr id="6" name="Text 4"/>
           <p:cNvSpPr/>
           <p:nvPr/>
         </p:nvSpPr>
@@ -5853,7 +5716,7 @@
       </p:sp>
       <p:sp>
         <p:nvSpPr>
-          <p:cNvPr id="9" name="Text 7"/>
+          <p:cNvPr id="7" name="Text 5"/>
           <p:cNvSpPr/>
           <p:nvPr/>
         </p:nvSpPr>
@@ -5915,7 +5778,7 @@
       </p:sp>
       <p:sp>
         <p:nvSpPr>
-          <p:cNvPr id="10" name="Text 8"/>
+          <p:cNvPr id="8" name="Text 6"/>
           <p:cNvSpPr/>
           <p:nvPr/>
         </p:nvSpPr>
@@ -5977,7 +5840,7 @@
       </p:sp>
       <p:sp>
         <p:nvSpPr>
-          <p:cNvPr id="11" name="Shape 9"/>
+          <p:cNvPr id="9" name="Shape 7"/>
           <p:cNvSpPr/>
           <p:nvPr/>
         </p:nvSpPr>
@@ -6002,7 +5865,7 @@
       </p:sp>
       <p:sp>
         <p:nvSpPr>
-          <p:cNvPr id="12" name="Text 10"/>
+          <p:cNvPr id="10" name="Text 8"/>
           <p:cNvSpPr/>
           <p:nvPr/>
         </p:nvSpPr>
@@ -6041,7 +5904,7 @@
       </p:sp>
       <p:sp>
         <p:nvSpPr>
-          <p:cNvPr id="13" name="Shape 11"/>
+          <p:cNvPr id="11" name="Shape 9"/>
           <p:cNvSpPr/>
           <p:nvPr/>
         </p:nvSpPr>
@@ -6066,7 +5929,7 @@
       </p:sp>
       <p:sp>
         <p:nvSpPr>
-          <p:cNvPr id="14" name="Text 12"/>
+          <p:cNvPr id="12" name="Text 10"/>
           <p:cNvSpPr/>
           <p:nvPr/>
         </p:nvSpPr>
@@ -6105,7 +5968,7 @@
       </p:sp>
       <p:sp>
         <p:nvSpPr>
-          <p:cNvPr id="15" name="Shape 13"/>
+          <p:cNvPr id="13" name="Shape 11"/>
           <p:cNvSpPr/>
           <p:nvPr/>
         </p:nvSpPr>
@@ -6130,7 +5993,7 @@
       </p:sp>
       <p:sp>
         <p:nvSpPr>
-          <p:cNvPr id="16" name="Text 14"/>
+          <p:cNvPr id="14" name="Text 12"/>
           <p:cNvSpPr/>
           <p:nvPr/>
         </p:nvSpPr>
@@ -6169,7 +6032,7 @@
       </p:sp>
       <p:sp>
         <p:nvSpPr>
-          <p:cNvPr id="17" name="Shape 15"/>
+          <p:cNvPr id="15" name="Shape 13"/>
           <p:cNvSpPr/>
           <p:nvPr/>
         </p:nvSpPr>
@@ -6194,7 +6057,7 @@
       </p:sp>
       <p:sp>
         <p:nvSpPr>
-          <p:cNvPr id="18" name="Text 16"/>
+          <p:cNvPr id="16" name="Text 14"/>
           <p:cNvSpPr/>
           <p:nvPr/>
         </p:nvSpPr>
@@ -6233,7 +6096,7 @@
       </p:sp>
       <p:sp>
         <p:nvSpPr>
-          <p:cNvPr id="19" name="Shape 17"/>
+          <p:cNvPr id="17" name="Shape 15"/>
           <p:cNvSpPr/>
           <p:nvPr/>
         </p:nvSpPr>
@@ -6258,7 +6121,7 @@
       </p:sp>
       <p:sp>
         <p:nvSpPr>
-          <p:cNvPr id="20" name="Text 18"/>
+          <p:cNvPr id="18" name="Text 16"/>
           <p:cNvSpPr/>
           <p:nvPr/>
         </p:nvSpPr>
@@ -6297,7 +6160,7 @@
       </p:sp>
       <p:sp>
         <p:nvSpPr>
-          <p:cNvPr id="21" name="Shape 19"/>
+          <p:cNvPr id="19" name="Shape 17"/>
           <p:cNvSpPr/>
           <p:nvPr/>
         </p:nvSpPr>
@@ -6322,7 +6185,7 @@
       </p:sp>
       <p:sp>
         <p:nvSpPr>
-          <p:cNvPr id="22" name="Text 20"/>
+          <p:cNvPr id="20" name="Text 18"/>
           <p:cNvSpPr/>
           <p:nvPr/>
         </p:nvSpPr>
@@ -6361,7 +6224,7 @@
       </p:sp>
       <p:sp>
         <p:nvSpPr>
-          <p:cNvPr id="23" name="Shape 21"/>
+          <p:cNvPr id="21" name="Shape 19"/>
           <p:cNvSpPr/>
           <p:nvPr/>
         </p:nvSpPr>
@@ -6386,7 +6249,7 @@
       </p:sp>
       <p:sp>
         <p:nvSpPr>
-          <p:cNvPr id="24" name="Text 22"/>
+          <p:cNvPr id="22" name="Text 20"/>
           <p:cNvSpPr/>
           <p:nvPr/>
         </p:nvSpPr>
@@ -6425,7 +6288,7 @@
       </p:sp>
       <p:sp>
         <p:nvSpPr>
-          <p:cNvPr id="25" name="Shape 23"/>
+          <p:cNvPr id="23" name="Shape 21"/>
           <p:cNvSpPr/>
           <p:nvPr/>
         </p:nvSpPr>
@@ -6450,7 +6313,7 @@
       </p:sp>
       <p:sp>
         <p:nvSpPr>
-          <p:cNvPr id="26" name="Text 24"/>
+          <p:cNvPr id="24" name="Text 22"/>
           <p:cNvSpPr/>
           <p:nvPr/>
         </p:nvSpPr>
@@ -6489,7 +6352,7 @@
       </p:sp>
       <p:sp>
         <p:nvSpPr>
-          <p:cNvPr id="27" name="Shape 25"/>
+          <p:cNvPr id="25" name="Shape 23"/>
           <p:cNvSpPr/>
           <p:nvPr/>
         </p:nvSpPr>
@@ -6514,7 +6377,7 @@
       </p:sp>
       <p:sp>
         <p:nvSpPr>
-          <p:cNvPr id="28" name="Text 26"/>
+          <p:cNvPr id="26" name="Text 24"/>
           <p:cNvSpPr/>
           <p:nvPr/>
         </p:nvSpPr>
@@ -6553,7 +6416,7 @@
       </p:sp>
       <p:sp>
         <p:nvSpPr>
-          <p:cNvPr id="29" name="Shape 27"/>
+          <p:cNvPr id="27" name="Shape 25"/>
           <p:cNvSpPr/>
           <p:nvPr/>
         </p:nvSpPr>
@@ -6578,7 +6441,7 @@
       </p:sp>
       <p:sp>
         <p:nvSpPr>
-          <p:cNvPr id="30" name="Text 28"/>
+          <p:cNvPr id="28" name="Text 26"/>
           <p:cNvSpPr/>
           <p:nvPr/>
         </p:nvSpPr>
@@ -6617,7 +6480,7 @@
       </p:sp>
       <p:sp>
         <p:nvSpPr>
-          <p:cNvPr id="31" name="Shape 29"/>
+          <p:cNvPr id="29" name="Shape 27"/>
           <p:cNvSpPr/>
           <p:nvPr/>
         </p:nvSpPr>
@@ -6642,7 +6505,7 @@
       </p:sp>
       <p:sp>
         <p:nvSpPr>
-          <p:cNvPr id="32" name="Text 30"/>
+          <p:cNvPr id="30" name="Text 28"/>
           <p:cNvSpPr/>
           <p:nvPr/>
         </p:nvSpPr>
@@ -6681,7 +6544,7 @@
       </p:sp>
       <p:sp>
         <p:nvSpPr>
-          <p:cNvPr id="33" name="Shape 31"/>
+          <p:cNvPr id="31" name="Shape 29"/>
           <p:cNvSpPr/>
           <p:nvPr/>
         </p:nvSpPr>
@@ -6706,7 +6569,7 @@
       </p:sp>
       <p:sp>
         <p:nvSpPr>
-          <p:cNvPr id="34" name="Text 32"/>
+          <p:cNvPr id="32" name="Text 30"/>
           <p:cNvSpPr/>
           <p:nvPr/>
         </p:nvSpPr>
@@ -6745,7 +6608,7 @@
       </p:sp>
       <p:sp>
         <p:nvSpPr>
-          <p:cNvPr id="35" name="Shape 33"/>
+          <p:cNvPr id="33" name="Shape 31"/>
           <p:cNvSpPr/>
           <p:nvPr/>
         </p:nvSpPr>
@@ -6770,7 +6633,7 @@
       </p:sp>
       <p:sp>
         <p:nvSpPr>
-          <p:cNvPr id="36" name="Text 34"/>
+          <p:cNvPr id="34" name="Text 32"/>
           <p:cNvSpPr/>
           <p:nvPr/>
         </p:nvSpPr>
@@ -6809,7 +6672,7 @@
       </p:sp>
       <p:sp>
         <p:nvSpPr>
-          <p:cNvPr id="37" name="Shape 35"/>
+          <p:cNvPr id="35" name="Shape 33"/>
           <p:cNvSpPr/>
           <p:nvPr/>
         </p:nvSpPr>
@@ -6834,7 +6697,7 @@
       </p:sp>
       <p:sp>
         <p:nvSpPr>
-          <p:cNvPr id="38" name="Text 36"/>
+          <p:cNvPr id="36" name="Text 34"/>
           <p:cNvSpPr/>
           <p:nvPr/>
         </p:nvSpPr>
@@ -6873,7 +6736,7 @@
       </p:sp>
       <p:sp>
         <p:nvSpPr>
-          <p:cNvPr id="39" name="Shape 37"/>
+          <p:cNvPr id="37" name="Shape 35"/>
           <p:cNvSpPr/>
           <p:nvPr/>
         </p:nvSpPr>
@@ -6898,7 +6761,7 @@
       </p:sp>
       <p:sp>
         <p:nvSpPr>
-          <p:cNvPr id="40" name="Text 38"/>
+          <p:cNvPr id="38" name="Text 36"/>
           <p:cNvSpPr/>
           <p:nvPr/>
         </p:nvSpPr>
@@ -6937,7 +6800,7 @@
       </p:sp>
       <p:sp>
         <p:nvSpPr>
-          <p:cNvPr id="41" name="Shape 39"/>
+          <p:cNvPr id="39" name="Shape 37"/>
           <p:cNvSpPr/>
           <p:nvPr/>
         </p:nvSpPr>
@@ -6962,7 +6825,7 @@
       </p:sp>
       <p:sp>
         <p:nvSpPr>
-          <p:cNvPr id="42" name="Text 40"/>
+          <p:cNvPr id="40" name="Text 38"/>
           <p:cNvSpPr/>
           <p:nvPr/>
         </p:nvSpPr>
@@ -7001,7 +6864,7 @@
       </p:sp>
       <p:sp>
         <p:nvSpPr>
-          <p:cNvPr id="43" name="Text 41"/>
+          <p:cNvPr id="41" name="Text 39"/>
           <p:cNvSpPr/>
           <p:nvPr/>
         </p:nvSpPr>
@@ -7040,7 +6903,7 @@
       </p:sp>
       <p:sp>
         <p:nvSpPr>
-          <p:cNvPr id="44" name="Shape 42"/>
+          <p:cNvPr id="42" name="Shape 40"/>
           <p:cNvSpPr/>
           <p:nvPr/>
         </p:nvSpPr>
@@ -7069,7 +6932,7 @@
       </p:sp>
       <p:sp>
         <p:nvSpPr>
-          <p:cNvPr id="45" name="Text 43"/>
+          <p:cNvPr id="43" name="Text 41"/>
           <p:cNvSpPr/>
           <p:nvPr/>
         </p:nvSpPr>
@@ -8227,7 +8090,7 @@
                 <a:ea typeface="Cambria" pitchFamily="34" charset="-122"/>
                 <a:cs typeface="Cambria" pitchFamily="34" charset="-120"/>
               </a:rPr>
-              <a:t>I — ending well, forward</a:t>
+              <a:t>What lives on?</a:t>
             </a:r>
             <a:endParaRPr lang="en-US" sz="3000" dirty="0"/>
           </a:p>
@@ -8235,110 +8098,85 @@
       </p:sp>
       <p:sp>
         <p:nvSpPr>
-          <p:cNvPr id="3" name="Shape 1"/>
-          <p:cNvSpPr/>
-          <p:nvPr/>
-        </p:nvSpPr>
-        <p:spPr>
-          <a:xfrm>
-            <a:off x="8362188" y="41148"/>
-            <a:ext cx="246888" cy="246888"/>
-          </a:xfrm>
-          <a:prstGeom prst="ellipse">
-            <a:avLst/>
-          </a:prstGeom>
-          <a:solidFill>
-            <a:srgbClr val="1F3A4D"/>
-          </a:solidFill>
-          <a:ln/>
-        </p:spPr>
-      </p:sp>
-      <p:sp>
-        <p:nvSpPr>
-          <p:cNvPr id="4" name="Shape 2"/>
-          <p:cNvSpPr/>
-          <p:nvPr/>
-        </p:nvSpPr>
-        <p:spPr>
-          <a:xfrm>
-            <a:off x="8212409" y="411480"/>
-            <a:ext cx="164592" cy="164592"/>
-          </a:xfrm>
-          <a:prstGeom prst="ellipse">
-            <a:avLst/>
-          </a:prstGeom>
-          <a:solidFill>
-            <a:srgbClr val="2E6E6E">
-              <a:alpha val="35000"/>
-            </a:srgbClr>
-          </a:solidFill>
-          <a:ln/>
-        </p:spPr>
+          <p:cNvPr id="3" name="Text 1"/>
+          <p:cNvSpPr/>
+          <p:nvPr/>
+        </p:nvSpPr>
+        <p:spPr>
+          <a:xfrm>
+            <a:off x="7726680" y="237744"/>
+            <a:ext cx="960120" cy="402336"/>
+          </a:xfrm>
+          <a:prstGeom prst="rect">
+            <a:avLst/>
+          </a:prstGeom>
+          <a:noFill/>
+          <a:ln/>
+        </p:spPr>
+        <p:txBody>
+          <a:bodyPr wrap="square" lIns="0" tIns="0" rIns="0" bIns="0" rtlCol="0" anchor="ctr"/>
+          <a:lstStyle/>
+          <a:p>
+            <a:pPr algn="r" indent="0" marL="0">
+              <a:buNone/>
+            </a:pPr>
+            <a:r>
+              <a:rPr lang="en-US" sz="2400" b="1" dirty="0">
+                <a:solidFill>
+                  <a:srgbClr val="1F3A4D"/>
+                </a:solidFill>
+                <a:latin typeface="Cambria" pitchFamily="34" charset="0"/>
+                <a:ea typeface="Cambria" pitchFamily="34" charset="-122"/>
+                <a:cs typeface="Cambria" pitchFamily="34" charset="-120"/>
+              </a:rPr>
+              <a:t>Q3</a:t>
+            </a:r>
+            <a:endParaRPr lang="en-US" sz="2400" dirty="0"/>
+          </a:p>
+        </p:txBody>
+      </p:sp>
+      <p:sp>
+        <p:nvSpPr>
+          <p:cNvPr id="4" name="Text 2"/>
+          <p:cNvSpPr/>
+          <p:nvPr/>
+        </p:nvSpPr>
+        <p:spPr>
+          <a:xfrm>
+            <a:off x="6675120" y="640080"/>
+            <a:ext cx="2011680" cy="201168"/>
+          </a:xfrm>
+          <a:prstGeom prst="rect">
+            <a:avLst/>
+          </a:prstGeom>
+          <a:noFill/>
+          <a:ln/>
+        </p:spPr>
+        <p:txBody>
+          <a:bodyPr wrap="square" lIns="0" tIns="0" rIns="0" bIns="0" rtlCol="0" anchor="ctr"/>
+          <a:lstStyle/>
+          <a:p>
+            <a:pPr algn="r" indent="0" marL="0">
+              <a:buNone/>
+            </a:pPr>
+            <a:r>
+              <a:rPr lang="en-US" sz="900" b="1" spc="200" kern="0" dirty="0">
+                <a:solidFill>
+                  <a:srgbClr val="888888"/>
+                </a:solidFill>
+                <a:latin typeface="Calibri" pitchFamily="34" charset="0"/>
+                <a:ea typeface="Calibri" pitchFamily="34" charset="-122"/>
+                <a:cs typeface="Calibri" pitchFamily="34" charset="-120"/>
+              </a:rPr>
+              <a:t>THE LEGACY</a:t>
+            </a:r>
+            <a:endParaRPr lang="en-US" sz="900" dirty="0"/>
+          </a:p>
+        </p:txBody>
       </p:sp>
       <p:sp>
         <p:nvSpPr>
           <p:cNvPr id="5" name="Shape 3"/>
-          <p:cNvSpPr/>
-          <p:nvPr/>
-        </p:nvSpPr>
-        <p:spPr>
-          <a:xfrm>
-            <a:off x="8594263" y="411480"/>
-            <a:ext cx="164592" cy="164592"/>
-          </a:xfrm>
-          <a:prstGeom prst="ellipse">
-            <a:avLst/>
-          </a:prstGeom>
-          <a:solidFill>
-            <a:srgbClr val="C08A2E">
-              <a:alpha val="35000"/>
-            </a:srgbClr>
-          </a:solidFill>
-          <a:ln/>
-        </p:spPr>
-      </p:sp>
-      <p:sp>
-        <p:nvSpPr>
-          <p:cNvPr id="6" name="Text 4"/>
-          <p:cNvSpPr/>
-          <p:nvPr/>
-        </p:nvSpPr>
-        <p:spPr>
-          <a:xfrm>
-            <a:off x="8028432" y="658368"/>
-            <a:ext cx="914400" cy="201168"/>
-          </a:xfrm>
-          <a:prstGeom prst="rect">
-            <a:avLst/>
-          </a:prstGeom>
-          <a:noFill/>
-          <a:ln/>
-        </p:spPr>
-        <p:txBody>
-          <a:bodyPr wrap="square" rtlCol="0" anchor="ctr"/>
-          <a:lstStyle/>
-          <a:p>
-            <a:pPr algn="ctr" indent="0" marL="0">
-              <a:buNone/>
-            </a:pPr>
-            <a:r>
-              <a:rPr lang="en-US" sz="900" b="1" spc="200" kern="0" dirty="0">
-                <a:solidFill>
-                  <a:srgbClr val="1F3A4D"/>
-                </a:solidFill>
-                <a:latin typeface="Calibri" pitchFamily="34" charset="0"/>
-                <a:ea typeface="Calibri" pitchFamily="34" charset="-122"/>
-                <a:cs typeface="Calibri" pitchFamily="34" charset="-120"/>
-              </a:rPr>
-              <a:t>I</a:t>
-            </a:r>
-            <a:endParaRPr lang="en-US" sz="900" dirty="0"/>
-          </a:p>
-        </p:txBody>
-      </p:sp>
-      <p:sp>
-        <p:nvSpPr>
-          <p:cNvPr id="7" name="Shape 5"/>
           <p:cNvSpPr/>
           <p:nvPr/>
         </p:nvSpPr>
@@ -8360,7 +8198,7 @@
       </p:sp>
       <p:sp>
         <p:nvSpPr>
-          <p:cNvPr id="8" name="Text 6"/>
+          <p:cNvPr id="6" name="Text 4"/>
           <p:cNvSpPr/>
           <p:nvPr/>
         </p:nvSpPr>
@@ -8399,7 +8237,7 @@
       </p:sp>
       <p:sp>
         <p:nvSpPr>
-          <p:cNvPr id="9" name="Text 7"/>
+          <p:cNvPr id="7" name="Text 5"/>
           <p:cNvSpPr/>
           <p:nvPr/>
         </p:nvSpPr>
@@ -8461,7 +8299,7 @@
       </p:sp>
       <p:sp>
         <p:nvSpPr>
-          <p:cNvPr id="10" name="Shape 8"/>
+          <p:cNvPr id="8" name="Shape 6"/>
           <p:cNvSpPr/>
           <p:nvPr/>
         </p:nvSpPr>
@@ -8483,7 +8321,7 @@
       </p:sp>
       <p:sp>
         <p:nvSpPr>
-          <p:cNvPr id="11" name="Text 9"/>
+          <p:cNvPr id="9" name="Text 7"/>
           <p:cNvSpPr/>
           <p:nvPr/>
         </p:nvSpPr>
@@ -8522,7 +8360,7 @@
       </p:sp>
       <p:sp>
         <p:nvSpPr>
-          <p:cNvPr id="12" name="Text 10"/>
+          <p:cNvPr id="10" name="Text 8"/>
           <p:cNvSpPr/>
           <p:nvPr/>
         </p:nvSpPr>
@@ -8584,7 +8422,7 @@
       </p:sp>
       <p:sp>
         <p:nvSpPr>
-          <p:cNvPr id="13" name="Shape 11"/>
+          <p:cNvPr id="11" name="Shape 9"/>
           <p:cNvSpPr/>
           <p:nvPr/>
         </p:nvSpPr>
@@ -8606,7 +8444,7 @@
       </p:sp>
       <p:sp>
         <p:nvSpPr>
-          <p:cNvPr id="14" name="Text 12"/>
+          <p:cNvPr id="12" name="Text 10"/>
           <p:cNvSpPr/>
           <p:nvPr/>
         </p:nvSpPr>
@@ -8645,7 +8483,7 @@
       </p:sp>
       <p:sp>
         <p:nvSpPr>
-          <p:cNvPr id="15" name="Text 13"/>
+          <p:cNvPr id="13" name="Text 11"/>
           <p:cNvSpPr/>
           <p:nvPr/>
         </p:nvSpPr>
@@ -8707,7 +8545,7 @@
       </p:sp>
       <p:sp>
         <p:nvSpPr>
-          <p:cNvPr id="16" name="Text 14"/>
+          <p:cNvPr id="14" name="Text 12"/>
           <p:cNvSpPr/>
           <p:nvPr/>
         </p:nvSpPr>

</xml_diff>